<commit_message>
Fix spelling errors in courses.
</commit_message>
<xml_diff>
--- a/courses/pptx/23.pptx
+++ b/courses/pptx/23.pptx
@@ -3108,7 +3108,7 @@
               </a:defRPr>
             </a:pPr>
             <a:r>
-              <a:t>为 MapMartix&lt;&gt; 返回的二维元组生成csv或xls文件，然后在表格软件中分析该矩阵。</a:t>
+              <a:t>为 MapMatrix&lt;&gt; 返回的二维元组生成csv或xls文件，然后在表格软件中分析该矩阵。</a:t>
             </a:r>
           </a:p>
           <a:p>
@@ -3145,7 +3145,7 @@
               </a:defRPr>
             </a:pPr>
             <a:r>
-              <a:t>为 MapMartix&lt;&gt; 返回的二维元组添加首行和首列（标题行与标题列）。</a:t>
+              <a:t>为 MapMatrix&lt;&gt; 返回的二维元组添加首行和首列（标题行与标题列）。</a:t>
             </a:r>
           </a:p>
           <a:p>
@@ -3238,7 +3238,7 @@
               <a:t>type</a:t>
             </a:r>
             <a:r>
-              <a:t> MapMartix2&lt;Source </a:t>
+              <a:t> MapMatrix2&lt;Source </a:t>
             </a:r>
             <a:r>
               <a:rPr>

</xml_diff>